<commit_message>
Regenerate PowerPoint for song #1 in fubc-en
</commit_message>
<xml_diff>
--- a/fubc-en/1-Teach me Your way, O Lord.pptx
+++ b/fubc-en/1-Teach me Your way, O Lord.pptx
@@ -9,9 +9,10 @@
     <p:sldId id="257" r:id="rId3"/>
     <p:sldId id="258" r:id="rId4"/>
     <p:sldId id="259" r:id="rId5"/>
+    <p:sldId id="260" r:id="rId6"/>
   </p:sldIdLst>
   <p:notesMasterIdLst>
-    <p:notesMasterId r:id="rId6"/>
+    <p:notesMasterId r:id="rId7"/>
   </p:notesMasterIdLst>
   <p:sldSz cx="12192000" cy="6858000"/>
   <p:notesSz cx="6858000" cy="12192000"/>
@@ -793,6 +794,94 @@
             <a:fld id="{F7021451-1387-4CA6-816F-3879F97B5CBC}" type="slidenum">
               <a:rPr lang="en-US"/>
               <a:t>4</a:t>
+            </a:fld>
+            <a:endParaRPr lang="en-US"/>
+          </a:p>
+        </p:txBody>
+      </p:sp>
+    </p:spTree>
+    <p:extLst>
+      <p:ext uri="{BB962C8B-B14F-4D97-AF65-F5344CB8AC3E}">
+        <p14:creationId xmlns:p14="http://schemas.microsoft.com/office/powerpoint/2010/main" val="1024086991"/>
+      </p:ext>
+    </p:extLst>
+  </p:cSld>
+  <p:clrMapOvr>
+    <a:masterClrMapping/>
+  </p:clrMapOvr>
+</p:notes>
+</file>
+
+<file path=ppt/notesSlides/notesSlide5.xml><?xml version="1.0" encoding="utf-8"?>
+<p:notes xmlns:a="http://schemas.openxmlformats.org/drawingml/2006/main" xmlns:r="http://schemas.openxmlformats.org/officeDocument/2006/relationships" xmlns:p="http://schemas.openxmlformats.org/presentationml/2006/main">
+  <p:cSld>
+    <p:spTree>
+      <p:nvGrpSpPr>
+        <p:cNvPr id="1" name=""/>
+        <p:cNvGrpSpPr/>
+        <p:nvPr/>
+      </p:nvGrpSpPr>
+      <p:grpSpPr>
+        <a:xfrm>
+          <a:off x="0" y="0"/>
+          <a:ext cx="0" cy="0"/>
+          <a:chOff x="0" y="0"/>
+          <a:chExt cx="0" cy="0"/>
+        </a:xfrm>
+      </p:grpSpPr>
+      <p:sp>
+        <p:nvSpPr>
+          <p:cNvPr id="2" name="Slide Image Placeholder 1"/>
+          <p:cNvSpPr>
+            <a:spLocks noGrp="1" noRot="1" noChangeAspect="1"/>
+          </p:cNvSpPr>
+          <p:nvPr>
+            <p:ph type="sldImg"/>
+          </p:nvPr>
+        </p:nvSpPr>
+        <p:spPr/>
+      </p:sp>
+      <p:sp>
+        <p:nvSpPr>
+          <p:cNvPr id="3" name="Notes Placeholder 2"/>
+          <p:cNvSpPr>
+            <a:spLocks noGrp="1"/>
+          </p:cNvSpPr>
+          <p:nvPr>
+            <p:ph type="body" idx="1"/>
+          </p:nvPr>
+        </p:nvSpPr>
+        <p:spPr/>
+        <p:txBody>
+          <a:bodyPr/>
+          <a:lstStyle/>
+          <a:p>
+            <a:r>
+              <a:rPr lang="en-US" dirty="0"/>
+              <a:t/>
+            </a:r>
+            <a:endParaRPr lang="en-US" dirty="0"/>
+          </a:p>
+        </p:txBody>
+      </p:sp>
+      <p:sp>
+        <p:nvSpPr>
+          <p:cNvPr id="4" name="Slide Number Placeholder 3"/>
+          <p:cNvSpPr>
+            <a:spLocks noGrp="1"/>
+          </p:cNvSpPr>
+          <p:nvPr>
+            <p:ph type="sldNum" sz="quarter" idx="10"/>
+          </p:nvPr>
+        </p:nvSpPr>
+        <p:spPr/>
+        <p:txBody>
+          <a:bodyPr/>
+          <a:lstStyle/>
+          <a:p>
+            <a:fld id="{F7021451-1387-4CA6-816F-3879F97B5CBC}" type="slidenum">
+              <a:rPr lang="en-US"/>
+              <a:t>5</a:t>
             </a:fld>
             <a:endParaRPr lang="en-US"/>
           </a:p>
@@ -1167,7 +1256,7 @@
               <a:buNone/>
             </a:pPr>
             <a:r>
-              <a:rPr lang="en-US" sz="4000" b="1" dirty="0">
+              <a:rPr lang="en-US" sz="4800" b="1" dirty="0">
                 <a:solidFill>
                   <a:srgbClr val="FFFFFF"/>
                 </a:solidFill>
@@ -1175,60 +1264,9 @@
                 <a:ea typeface="Arial" pitchFamily="34" charset="-122"/>
                 <a:cs typeface="Arial" pitchFamily="34" charset="-120"/>
               </a:rPr>
-              <a:t>Teach me Your way, O Lord, teach me Your way!</a:t>
-            </a:r>
-            <a:endParaRPr lang="en-US" sz="4000" dirty="0"/>
-          </a:p>
-          <a:p>
-            <a:pPr algn="ctr" indent="0" marL="0">
-              <a:buNone/>
-            </a:pPr>
-            <a:r>
-              <a:rPr lang="en-US" sz="4000" b="1" dirty="0">
-                <a:solidFill>
-                  <a:srgbClr val="FFFFFF"/>
-                </a:solidFill>
-                <a:latin typeface="Arial" pitchFamily="34" charset="0"/>
-                <a:ea typeface="Arial" pitchFamily="34" charset="-122"/>
-                <a:cs typeface="Arial" pitchFamily="34" charset="-120"/>
-              </a:rPr>
-              <a:t>Your guiding grace afford, teach me Your way!</a:t>
-            </a:r>
-            <a:endParaRPr lang="en-US" sz="4000" dirty="0"/>
-          </a:p>
-          <a:p>
-            <a:pPr algn="ctr" indent="0" marL="0">
-              <a:buNone/>
-            </a:pPr>
-            <a:r>
-              <a:rPr lang="en-US" sz="4000" b="1" dirty="0">
-                <a:solidFill>
-                  <a:srgbClr val="FFFFFF"/>
-                </a:solidFill>
-                <a:latin typeface="Arial" pitchFamily="34" charset="0"/>
-                <a:ea typeface="Arial" pitchFamily="34" charset="-122"/>
-                <a:cs typeface="Arial" pitchFamily="34" charset="-120"/>
-              </a:rPr>
-              <a:t>Help me to walk aright, more by faith, less by sight;</a:t>
-            </a:r>
-            <a:endParaRPr lang="en-US" sz="4000" dirty="0"/>
-          </a:p>
-          <a:p>
-            <a:pPr algn="ctr" indent="0" marL="0">
-              <a:buNone/>
-            </a:pPr>
-            <a:r>
-              <a:rPr lang="en-US" sz="4000" b="1" dirty="0">
-                <a:solidFill>
-                  <a:srgbClr val="FFFFFF"/>
-                </a:solidFill>
-                <a:latin typeface="Arial" pitchFamily="34" charset="0"/>
-                <a:ea typeface="Arial" pitchFamily="34" charset="-122"/>
-                <a:cs typeface="Arial" pitchFamily="34" charset="-120"/>
-              </a:rPr>
-              <a:t>Lead me with heavenly light, teach me Your way!</a:t>
-            </a:r>
-            <a:endParaRPr lang="en-US" sz="4000" dirty="0"/>
+              <a:t>Teach me Your way, O Lord</a:t>
+            </a:r>
+            <a:endParaRPr lang="en-US" sz="4800" dirty="0"/>
           </a:p>
         </p:txBody>
       </p:sp>
@@ -1289,7 +1327,7 @@
               <a:buNone/>
             </a:pPr>
             <a:r>
-              <a:rPr lang="en-US" sz="4000" b="1" dirty="0">
+              <a:rPr lang="en-US" sz="4800" b="1" dirty="0">
                 <a:solidFill>
                   <a:srgbClr val="FFFFFF"/>
                 </a:solidFill>
@@ -1297,16 +1335,16 @@
                 <a:ea typeface="Arial" pitchFamily="34" charset="-122"/>
                 <a:cs typeface="Arial" pitchFamily="34" charset="-120"/>
               </a:rPr>
-              <a:t>When I am sad at heart, teach me Your way!</a:t>
-            </a:r>
-            <a:endParaRPr lang="en-US" sz="4000" dirty="0"/>
+              <a:t>Teach me Your way, O Lord, teach me Your way!</a:t>
+            </a:r>
+            <a:endParaRPr lang="en-US" sz="4800" dirty="0"/>
           </a:p>
           <a:p>
             <a:pPr algn="ctr" indent="0" marL="0">
               <a:buNone/>
             </a:pPr>
             <a:r>
-              <a:rPr lang="en-US" sz="4000" b="1" dirty="0">
+              <a:rPr lang="en-US" sz="4800" b="1" dirty="0">
                 <a:solidFill>
                   <a:srgbClr val="FFFFFF"/>
                 </a:solidFill>
@@ -1314,16 +1352,16 @@
                 <a:ea typeface="Arial" pitchFamily="34" charset="-122"/>
                 <a:cs typeface="Arial" pitchFamily="34" charset="-120"/>
               </a:rPr>
-              <a:t>When earthly joys depart, teach me Your way!</a:t>
-            </a:r>
-            <a:endParaRPr lang="en-US" sz="4000" dirty="0"/>
+              <a:t>Your guiding grace afford, teach me Your way!</a:t>
+            </a:r>
+            <a:endParaRPr lang="en-US" sz="4800" dirty="0"/>
           </a:p>
           <a:p>
             <a:pPr algn="ctr" indent="0" marL="0">
               <a:buNone/>
             </a:pPr>
             <a:r>
-              <a:rPr lang="en-US" sz="4000" b="1" dirty="0">
+              <a:rPr lang="en-US" sz="4800" b="1" dirty="0">
                 <a:solidFill>
                   <a:srgbClr val="FFFFFF"/>
                 </a:solidFill>
@@ -1331,16 +1369,16 @@
                 <a:ea typeface="Arial" pitchFamily="34" charset="-122"/>
                 <a:cs typeface="Arial" pitchFamily="34" charset="-120"/>
               </a:rPr>
-              <a:t>In hours of loneliness, in times of dire distress,</a:t>
-            </a:r>
-            <a:endParaRPr lang="en-US" sz="4000" dirty="0"/>
+              <a:t>Help me to walk aright, more by faith, less by sight;</a:t>
+            </a:r>
+            <a:endParaRPr lang="en-US" sz="4800" dirty="0"/>
           </a:p>
           <a:p>
             <a:pPr algn="ctr" indent="0" marL="0">
               <a:buNone/>
             </a:pPr>
             <a:r>
-              <a:rPr lang="en-US" sz="4000" b="1" dirty="0">
+              <a:rPr lang="en-US" sz="4800" b="1" dirty="0">
                 <a:solidFill>
                   <a:srgbClr val="FFFFFF"/>
                 </a:solidFill>
@@ -1348,9 +1386,9 @@
                 <a:ea typeface="Arial" pitchFamily="34" charset="-122"/>
                 <a:cs typeface="Arial" pitchFamily="34" charset="-120"/>
               </a:rPr>
-              <a:t>In failure or success, teach me Your way!</a:t>
-            </a:r>
-            <a:endParaRPr lang="en-US" sz="4000" dirty="0"/>
+              <a:t>Lead me with heavenly light, teach me Your way!</a:t>
+            </a:r>
+            <a:endParaRPr lang="en-US" sz="4800" dirty="0"/>
           </a:p>
         </p:txBody>
       </p:sp>
@@ -1411,7 +1449,7 @@
               <a:buNone/>
             </a:pPr>
             <a:r>
-              <a:rPr lang="en-US" sz="4000" b="1" dirty="0">
+              <a:rPr lang="en-US" sz="4800" b="1" dirty="0">
                 <a:solidFill>
                   <a:srgbClr val="FFFFFF"/>
                 </a:solidFill>
@@ -1419,16 +1457,16 @@
                 <a:ea typeface="Arial" pitchFamily="34" charset="-122"/>
                 <a:cs typeface="Arial" pitchFamily="34" charset="-120"/>
               </a:rPr>
-              <a:t>When doubts and fears arise, teach me Your way!</a:t>
-            </a:r>
-            <a:endParaRPr lang="en-US" sz="4000" dirty="0"/>
+              <a:t>When I am sad at heart, teach me Your way!</a:t>
+            </a:r>
+            <a:endParaRPr lang="en-US" sz="4800" dirty="0"/>
           </a:p>
           <a:p>
             <a:pPr algn="ctr" indent="0" marL="0">
               <a:buNone/>
             </a:pPr>
             <a:r>
-              <a:rPr lang="en-US" sz="4000" b="1" dirty="0">
+              <a:rPr lang="en-US" sz="4800" b="1" dirty="0">
                 <a:solidFill>
                   <a:srgbClr val="FFFFFF"/>
                 </a:solidFill>
@@ -1436,16 +1474,16 @@
                 <a:ea typeface="Arial" pitchFamily="34" charset="-122"/>
                 <a:cs typeface="Arial" pitchFamily="34" charset="-120"/>
               </a:rPr>
-              <a:t>When storm clouds fill the skies, teach me Your way!</a:t>
-            </a:r>
-            <a:endParaRPr lang="en-US" sz="4000" dirty="0"/>
+              <a:t>When earthly joys depart, teach me Your way!</a:t>
+            </a:r>
+            <a:endParaRPr lang="en-US" sz="4800" dirty="0"/>
           </a:p>
           <a:p>
             <a:pPr algn="ctr" indent="0" marL="0">
               <a:buNone/>
             </a:pPr>
             <a:r>
-              <a:rPr lang="en-US" sz="4000" b="1" dirty="0">
+              <a:rPr lang="en-US" sz="4800" b="1" dirty="0">
                 <a:solidFill>
                   <a:srgbClr val="FFFFFF"/>
                 </a:solidFill>
@@ -1453,16 +1491,16 @@
                 <a:ea typeface="Arial" pitchFamily="34" charset="-122"/>
                 <a:cs typeface="Arial" pitchFamily="34" charset="-120"/>
               </a:rPr>
-              <a:t>Shine through the wind and rain, through sorrow, grief and pain;</a:t>
-            </a:r>
-            <a:endParaRPr lang="en-US" sz="4000" dirty="0"/>
+              <a:t>In hours of loneliness, in times of dire distress,</a:t>
+            </a:r>
+            <a:endParaRPr lang="en-US" sz="4800" dirty="0"/>
           </a:p>
           <a:p>
             <a:pPr algn="ctr" indent="0" marL="0">
               <a:buNone/>
             </a:pPr>
             <a:r>
-              <a:rPr lang="en-US" sz="4000" b="1" dirty="0">
+              <a:rPr lang="en-US" sz="4800" b="1" dirty="0">
                 <a:solidFill>
                   <a:srgbClr val="FFFFFF"/>
                 </a:solidFill>
@@ -1470,9 +1508,9 @@
                 <a:ea typeface="Arial" pitchFamily="34" charset="-122"/>
                 <a:cs typeface="Arial" pitchFamily="34" charset="-120"/>
               </a:rPr>
-              <a:t>Make now my pathway plain, teach me Your way!</a:t>
-            </a:r>
-            <a:endParaRPr lang="en-US" sz="4000" dirty="0"/>
+              <a:t>In failure or success, teach me Your way!</a:t>
+            </a:r>
+            <a:endParaRPr lang="en-US" sz="4800" dirty="0"/>
           </a:p>
         </p:txBody>
       </p:sp>
@@ -1533,7 +1571,129 @@
               <a:buNone/>
             </a:pPr>
             <a:r>
-              <a:rPr lang="en-US" sz="4000" b="1" dirty="0">
+              <a:rPr lang="en-US" sz="4800" b="1" dirty="0">
+                <a:solidFill>
+                  <a:srgbClr val="FFFFFF"/>
+                </a:solidFill>
+                <a:latin typeface="Arial" pitchFamily="34" charset="0"/>
+                <a:ea typeface="Arial" pitchFamily="34" charset="-122"/>
+                <a:cs typeface="Arial" pitchFamily="34" charset="-120"/>
+              </a:rPr>
+              <a:t>When doubts and fears arise, teach me Your way!</a:t>
+            </a:r>
+            <a:endParaRPr lang="en-US" sz="4800" dirty="0"/>
+          </a:p>
+          <a:p>
+            <a:pPr algn="ctr" indent="0" marL="0">
+              <a:buNone/>
+            </a:pPr>
+            <a:r>
+              <a:rPr lang="en-US" sz="4800" b="1" dirty="0">
+                <a:solidFill>
+                  <a:srgbClr val="FFFFFF"/>
+                </a:solidFill>
+                <a:latin typeface="Arial" pitchFamily="34" charset="0"/>
+                <a:ea typeface="Arial" pitchFamily="34" charset="-122"/>
+                <a:cs typeface="Arial" pitchFamily="34" charset="-120"/>
+              </a:rPr>
+              <a:t>When storm clouds fill the skies, teach me Your way!</a:t>
+            </a:r>
+            <a:endParaRPr lang="en-US" sz="4800" dirty="0"/>
+          </a:p>
+          <a:p>
+            <a:pPr algn="ctr" indent="0" marL="0">
+              <a:buNone/>
+            </a:pPr>
+            <a:r>
+              <a:rPr lang="en-US" sz="4800" b="1" dirty="0">
+                <a:solidFill>
+                  <a:srgbClr val="FFFFFF"/>
+                </a:solidFill>
+                <a:latin typeface="Arial" pitchFamily="34" charset="0"/>
+                <a:ea typeface="Arial" pitchFamily="34" charset="-122"/>
+                <a:cs typeface="Arial" pitchFamily="34" charset="-120"/>
+              </a:rPr>
+              <a:t>Shine through the wind and rain, through sorrow, grief and pain;</a:t>
+            </a:r>
+            <a:endParaRPr lang="en-US" sz="4800" dirty="0"/>
+          </a:p>
+          <a:p>
+            <a:pPr algn="ctr" indent="0" marL="0">
+              <a:buNone/>
+            </a:pPr>
+            <a:r>
+              <a:rPr lang="en-US" sz="4800" b="1" dirty="0">
+                <a:solidFill>
+                  <a:srgbClr val="FFFFFF"/>
+                </a:solidFill>
+                <a:latin typeface="Arial" pitchFamily="34" charset="0"/>
+                <a:ea typeface="Arial" pitchFamily="34" charset="-122"/>
+                <a:cs typeface="Arial" pitchFamily="34" charset="-120"/>
+              </a:rPr>
+              <a:t>Make now my pathway plain, teach me Your way!</a:t>
+            </a:r>
+            <a:endParaRPr lang="en-US" sz="4800" dirty="0"/>
+          </a:p>
+        </p:txBody>
+      </p:sp>
+    </p:spTree>
+  </p:cSld>
+  <p:clrMapOvr>
+    <a:masterClrMapping/>
+  </p:clrMapOvr>
+</p:sld>
+</file>
+
+<file path=ppt/slides/slide5.xml><?xml version="1.0" encoding="utf-8"?>
+<p:sld xmlns:a="http://schemas.openxmlformats.org/drawingml/2006/main" xmlns:r="http://schemas.openxmlformats.org/officeDocument/2006/relationships" xmlns:p="http://schemas.openxmlformats.org/presentationml/2006/main">
+  <p:cSld name="Slide 5">
+    <p:bg>
+      <p:bgPr>
+        <a:solidFill>
+          <a:srgbClr val="000000"/>
+        </a:solidFill>
+      </p:bgPr>
+    </p:bg>
+    <p:spTree>
+      <p:nvGrpSpPr>
+        <p:cNvPr id="1" name=""/>
+        <p:cNvGrpSpPr/>
+        <p:nvPr/>
+      </p:nvGrpSpPr>
+      <p:grpSpPr>
+        <a:xfrm>
+          <a:off x="0" y="0"/>
+          <a:ext cx="0" cy="0"/>
+          <a:chOff x="0" y="0"/>
+          <a:chExt cx="0" cy="0"/>
+        </a:xfrm>
+      </p:grpSpPr>
+      <p:sp>
+        <p:nvSpPr>
+          <p:cNvPr id="2" name="Text 0"/>
+          <p:cNvSpPr txBox="1"/>
+          <p:nvPr/>
+        </p:nvSpPr>
+        <p:spPr>
+          <a:xfrm>
+            <a:off x="548640" y="457200"/>
+            <a:ext cx="11064240" cy="5943600"/>
+          </a:xfrm>
+          <a:prstGeom prst="rect">
+            <a:avLst/>
+          </a:prstGeom>
+          <a:noFill/>
+          <a:ln/>
+        </p:spPr>
+        <p:txBody>
+          <a:bodyPr wrap="square" lIns="0" tIns="0" rIns="0" bIns="0" rtlCol="0" anchor="ctr"/>
+          <a:lstStyle/>
+          <a:p>
+            <a:pPr algn="ctr" indent="0" marL="0">
+              <a:buNone/>
+            </a:pPr>
+            <a:r>
+              <a:rPr lang="en-US" sz="4800" b="1" dirty="0">
                 <a:solidFill>
                   <a:srgbClr val="FFFFFF"/>
                 </a:solidFill>
@@ -1543,14 +1703,14 @@
               </a:rPr>
               <a:t>Long as my life shall last, teach me Your way!</a:t>
             </a:r>
-            <a:endParaRPr lang="en-US" sz="4000" dirty="0"/>
+            <a:endParaRPr lang="en-US" sz="4800" dirty="0"/>
           </a:p>
           <a:p>
             <a:pPr algn="ctr" indent="0" marL="0">
               <a:buNone/>
             </a:pPr>
             <a:r>
-              <a:rPr lang="en-US" sz="4000" b="1" dirty="0">
+              <a:rPr lang="en-US" sz="4800" b="1" dirty="0">
                 <a:solidFill>
                   <a:srgbClr val="FFFFFF"/>
                 </a:solidFill>
@@ -1560,14 +1720,14 @@
               </a:rPr>
               <a:t>Where’er my lot be cast, teach me Your way!</a:t>
             </a:r>
-            <a:endParaRPr lang="en-US" sz="4000" dirty="0"/>
+            <a:endParaRPr lang="en-US" sz="4800" dirty="0"/>
           </a:p>
           <a:p>
             <a:pPr algn="ctr" indent="0" marL="0">
               <a:buNone/>
             </a:pPr>
             <a:r>
-              <a:rPr lang="en-US" sz="4000" b="1" dirty="0">
+              <a:rPr lang="en-US" sz="4800" b="1" dirty="0">
                 <a:solidFill>
                   <a:srgbClr val="FFFFFF"/>
                 </a:solidFill>
@@ -1577,14 +1737,14 @@
               </a:rPr>
               <a:t>Until the race is run, until the journey’s done,</a:t>
             </a:r>
-            <a:endParaRPr lang="en-US" sz="4000" dirty="0"/>
+            <a:endParaRPr lang="en-US" sz="4800" dirty="0"/>
           </a:p>
           <a:p>
             <a:pPr algn="ctr" indent="0" marL="0">
               <a:buNone/>
             </a:pPr>
             <a:r>
-              <a:rPr lang="en-US" sz="4000" b="1" dirty="0">
+              <a:rPr lang="en-US" sz="4800" b="1" dirty="0">
                 <a:solidFill>
                   <a:srgbClr val="FFFFFF"/>
                 </a:solidFill>
@@ -1594,14 +1754,14 @@
               </a:rPr>
               <a:t>Until the crown is won, teach me Your way!</a:t>
             </a:r>
-            <a:endParaRPr lang="en-US" sz="4000" dirty="0"/>
+            <a:endParaRPr lang="en-US" sz="4800" dirty="0"/>
           </a:p>
           <a:p>
             <a:pPr algn="ctr" indent="0" marL="0">
               <a:buNone/>
             </a:pPr>
             <a:r>
-              <a:rPr lang="en-US" sz="4000" b="1" dirty="0">
+              <a:rPr lang="en-US" sz="4800" b="1" dirty="0">
                 <a:solidFill>
                   <a:srgbClr val="FFFFFF"/>
                 </a:solidFill>
@@ -1611,7 +1771,7 @@
               </a:rPr>
               <a:t>***</a:t>
             </a:r>
-            <a:endParaRPr lang="en-US" sz="4000" dirty="0"/>
+            <a:endParaRPr lang="en-US" sz="4800" dirty="0"/>
           </a:p>
         </p:txBody>
       </p:sp>

</xml_diff>

<commit_message>
Update PowerPoint for song #1 in FUBC - English
</commit_message>
<xml_diff>
--- a/fubc-en/1-Teach me Your way, O Lord.pptx
+++ b/fubc-en/1-Teach me Your way, O Lord.pptx
@@ -10,9 +10,13 @@
     <p:sldId id="258" r:id="rId4"/>
     <p:sldId id="259" r:id="rId5"/>
     <p:sldId id="260" r:id="rId6"/>
+    <p:sldId id="261" r:id="rId7"/>
+    <p:sldId id="262" r:id="rId8"/>
+    <p:sldId id="263" r:id="rId9"/>
+    <p:sldId id="264" r:id="rId10"/>
   </p:sldIdLst>
   <p:notesMasterIdLst>
-    <p:notesMasterId r:id="rId7"/>
+    <p:notesMasterId r:id="rId11"/>
   </p:notesMasterIdLst>
   <p:sldSz cx="12192000" cy="6858000"/>
   <p:notesSz cx="6858000" cy="12192000"/>
@@ -882,6 +886,358 @@
             <a:fld id="{F7021451-1387-4CA6-816F-3879F97B5CBC}" type="slidenum">
               <a:rPr lang="en-US"/>
               <a:t>5</a:t>
+            </a:fld>
+            <a:endParaRPr lang="en-US"/>
+          </a:p>
+        </p:txBody>
+      </p:sp>
+    </p:spTree>
+    <p:extLst>
+      <p:ext uri="{BB962C8B-B14F-4D97-AF65-F5344CB8AC3E}">
+        <p14:creationId xmlns:p14="http://schemas.microsoft.com/office/powerpoint/2010/main" val="1024086991"/>
+      </p:ext>
+    </p:extLst>
+  </p:cSld>
+  <p:clrMapOvr>
+    <a:masterClrMapping/>
+  </p:clrMapOvr>
+</p:notes>
+</file>
+
+<file path=ppt/notesSlides/notesSlide6.xml><?xml version="1.0" encoding="utf-8"?>
+<p:notes xmlns:a="http://schemas.openxmlformats.org/drawingml/2006/main" xmlns:r="http://schemas.openxmlformats.org/officeDocument/2006/relationships" xmlns:p="http://schemas.openxmlformats.org/presentationml/2006/main">
+  <p:cSld>
+    <p:spTree>
+      <p:nvGrpSpPr>
+        <p:cNvPr id="1" name=""/>
+        <p:cNvGrpSpPr/>
+        <p:nvPr/>
+      </p:nvGrpSpPr>
+      <p:grpSpPr>
+        <a:xfrm>
+          <a:off x="0" y="0"/>
+          <a:ext cx="0" cy="0"/>
+          <a:chOff x="0" y="0"/>
+          <a:chExt cx="0" cy="0"/>
+        </a:xfrm>
+      </p:grpSpPr>
+      <p:sp>
+        <p:nvSpPr>
+          <p:cNvPr id="2" name="Slide Image Placeholder 1"/>
+          <p:cNvSpPr>
+            <a:spLocks noGrp="1" noRot="1" noChangeAspect="1"/>
+          </p:cNvSpPr>
+          <p:nvPr>
+            <p:ph type="sldImg"/>
+          </p:nvPr>
+        </p:nvSpPr>
+        <p:spPr/>
+      </p:sp>
+      <p:sp>
+        <p:nvSpPr>
+          <p:cNvPr id="3" name="Notes Placeholder 2"/>
+          <p:cNvSpPr>
+            <a:spLocks noGrp="1"/>
+          </p:cNvSpPr>
+          <p:nvPr>
+            <p:ph type="body" idx="1"/>
+          </p:nvPr>
+        </p:nvSpPr>
+        <p:spPr/>
+        <p:txBody>
+          <a:bodyPr/>
+          <a:lstStyle/>
+          <a:p>
+            <a:r>
+              <a:rPr lang="en-US" dirty="0"/>
+              <a:t/>
+            </a:r>
+            <a:endParaRPr lang="en-US" dirty="0"/>
+          </a:p>
+        </p:txBody>
+      </p:sp>
+      <p:sp>
+        <p:nvSpPr>
+          <p:cNvPr id="4" name="Slide Number Placeholder 3"/>
+          <p:cNvSpPr>
+            <a:spLocks noGrp="1"/>
+          </p:cNvSpPr>
+          <p:nvPr>
+            <p:ph type="sldNum" sz="quarter" idx="10"/>
+          </p:nvPr>
+        </p:nvSpPr>
+        <p:spPr/>
+        <p:txBody>
+          <a:bodyPr/>
+          <a:lstStyle/>
+          <a:p>
+            <a:fld id="{F7021451-1387-4CA6-816F-3879F97B5CBC}" type="slidenum">
+              <a:rPr lang="en-US"/>
+              <a:t>6</a:t>
+            </a:fld>
+            <a:endParaRPr lang="en-US"/>
+          </a:p>
+        </p:txBody>
+      </p:sp>
+    </p:spTree>
+    <p:extLst>
+      <p:ext uri="{BB962C8B-B14F-4D97-AF65-F5344CB8AC3E}">
+        <p14:creationId xmlns:p14="http://schemas.microsoft.com/office/powerpoint/2010/main" val="1024086991"/>
+      </p:ext>
+    </p:extLst>
+  </p:cSld>
+  <p:clrMapOvr>
+    <a:masterClrMapping/>
+  </p:clrMapOvr>
+</p:notes>
+</file>
+
+<file path=ppt/notesSlides/notesSlide7.xml><?xml version="1.0" encoding="utf-8"?>
+<p:notes xmlns:a="http://schemas.openxmlformats.org/drawingml/2006/main" xmlns:r="http://schemas.openxmlformats.org/officeDocument/2006/relationships" xmlns:p="http://schemas.openxmlformats.org/presentationml/2006/main">
+  <p:cSld>
+    <p:spTree>
+      <p:nvGrpSpPr>
+        <p:cNvPr id="1" name=""/>
+        <p:cNvGrpSpPr/>
+        <p:nvPr/>
+      </p:nvGrpSpPr>
+      <p:grpSpPr>
+        <a:xfrm>
+          <a:off x="0" y="0"/>
+          <a:ext cx="0" cy="0"/>
+          <a:chOff x="0" y="0"/>
+          <a:chExt cx="0" cy="0"/>
+        </a:xfrm>
+      </p:grpSpPr>
+      <p:sp>
+        <p:nvSpPr>
+          <p:cNvPr id="2" name="Slide Image Placeholder 1"/>
+          <p:cNvSpPr>
+            <a:spLocks noGrp="1" noRot="1" noChangeAspect="1"/>
+          </p:cNvSpPr>
+          <p:nvPr>
+            <p:ph type="sldImg"/>
+          </p:nvPr>
+        </p:nvSpPr>
+        <p:spPr/>
+      </p:sp>
+      <p:sp>
+        <p:nvSpPr>
+          <p:cNvPr id="3" name="Notes Placeholder 2"/>
+          <p:cNvSpPr>
+            <a:spLocks noGrp="1"/>
+          </p:cNvSpPr>
+          <p:nvPr>
+            <p:ph type="body" idx="1"/>
+          </p:nvPr>
+        </p:nvSpPr>
+        <p:spPr/>
+        <p:txBody>
+          <a:bodyPr/>
+          <a:lstStyle/>
+          <a:p>
+            <a:r>
+              <a:rPr lang="en-US" dirty="0"/>
+              <a:t/>
+            </a:r>
+            <a:endParaRPr lang="en-US" dirty="0"/>
+          </a:p>
+        </p:txBody>
+      </p:sp>
+      <p:sp>
+        <p:nvSpPr>
+          <p:cNvPr id="4" name="Slide Number Placeholder 3"/>
+          <p:cNvSpPr>
+            <a:spLocks noGrp="1"/>
+          </p:cNvSpPr>
+          <p:nvPr>
+            <p:ph type="sldNum" sz="quarter" idx="10"/>
+          </p:nvPr>
+        </p:nvSpPr>
+        <p:spPr/>
+        <p:txBody>
+          <a:bodyPr/>
+          <a:lstStyle/>
+          <a:p>
+            <a:fld id="{F7021451-1387-4CA6-816F-3879F97B5CBC}" type="slidenum">
+              <a:rPr lang="en-US"/>
+              <a:t>7</a:t>
+            </a:fld>
+            <a:endParaRPr lang="en-US"/>
+          </a:p>
+        </p:txBody>
+      </p:sp>
+    </p:spTree>
+    <p:extLst>
+      <p:ext uri="{BB962C8B-B14F-4D97-AF65-F5344CB8AC3E}">
+        <p14:creationId xmlns:p14="http://schemas.microsoft.com/office/powerpoint/2010/main" val="1024086991"/>
+      </p:ext>
+    </p:extLst>
+  </p:cSld>
+  <p:clrMapOvr>
+    <a:masterClrMapping/>
+  </p:clrMapOvr>
+</p:notes>
+</file>
+
+<file path=ppt/notesSlides/notesSlide8.xml><?xml version="1.0" encoding="utf-8"?>
+<p:notes xmlns:a="http://schemas.openxmlformats.org/drawingml/2006/main" xmlns:r="http://schemas.openxmlformats.org/officeDocument/2006/relationships" xmlns:p="http://schemas.openxmlformats.org/presentationml/2006/main">
+  <p:cSld>
+    <p:spTree>
+      <p:nvGrpSpPr>
+        <p:cNvPr id="1" name=""/>
+        <p:cNvGrpSpPr/>
+        <p:nvPr/>
+      </p:nvGrpSpPr>
+      <p:grpSpPr>
+        <a:xfrm>
+          <a:off x="0" y="0"/>
+          <a:ext cx="0" cy="0"/>
+          <a:chOff x="0" y="0"/>
+          <a:chExt cx="0" cy="0"/>
+        </a:xfrm>
+      </p:grpSpPr>
+      <p:sp>
+        <p:nvSpPr>
+          <p:cNvPr id="2" name="Slide Image Placeholder 1"/>
+          <p:cNvSpPr>
+            <a:spLocks noGrp="1" noRot="1" noChangeAspect="1"/>
+          </p:cNvSpPr>
+          <p:nvPr>
+            <p:ph type="sldImg"/>
+          </p:nvPr>
+        </p:nvSpPr>
+        <p:spPr/>
+      </p:sp>
+      <p:sp>
+        <p:nvSpPr>
+          <p:cNvPr id="3" name="Notes Placeholder 2"/>
+          <p:cNvSpPr>
+            <a:spLocks noGrp="1"/>
+          </p:cNvSpPr>
+          <p:nvPr>
+            <p:ph type="body" idx="1"/>
+          </p:nvPr>
+        </p:nvSpPr>
+        <p:spPr/>
+        <p:txBody>
+          <a:bodyPr/>
+          <a:lstStyle/>
+          <a:p>
+            <a:r>
+              <a:rPr lang="en-US" dirty="0"/>
+              <a:t/>
+            </a:r>
+            <a:endParaRPr lang="en-US" dirty="0"/>
+          </a:p>
+        </p:txBody>
+      </p:sp>
+      <p:sp>
+        <p:nvSpPr>
+          <p:cNvPr id="4" name="Slide Number Placeholder 3"/>
+          <p:cNvSpPr>
+            <a:spLocks noGrp="1"/>
+          </p:cNvSpPr>
+          <p:nvPr>
+            <p:ph type="sldNum" sz="quarter" idx="10"/>
+          </p:nvPr>
+        </p:nvSpPr>
+        <p:spPr/>
+        <p:txBody>
+          <a:bodyPr/>
+          <a:lstStyle/>
+          <a:p>
+            <a:fld id="{F7021451-1387-4CA6-816F-3879F97B5CBC}" type="slidenum">
+              <a:rPr lang="en-US"/>
+              <a:t>8</a:t>
+            </a:fld>
+            <a:endParaRPr lang="en-US"/>
+          </a:p>
+        </p:txBody>
+      </p:sp>
+    </p:spTree>
+    <p:extLst>
+      <p:ext uri="{BB962C8B-B14F-4D97-AF65-F5344CB8AC3E}">
+        <p14:creationId xmlns:p14="http://schemas.microsoft.com/office/powerpoint/2010/main" val="1024086991"/>
+      </p:ext>
+    </p:extLst>
+  </p:cSld>
+  <p:clrMapOvr>
+    <a:masterClrMapping/>
+  </p:clrMapOvr>
+</p:notes>
+</file>
+
+<file path=ppt/notesSlides/notesSlide9.xml><?xml version="1.0" encoding="utf-8"?>
+<p:notes xmlns:a="http://schemas.openxmlformats.org/drawingml/2006/main" xmlns:r="http://schemas.openxmlformats.org/officeDocument/2006/relationships" xmlns:p="http://schemas.openxmlformats.org/presentationml/2006/main">
+  <p:cSld>
+    <p:spTree>
+      <p:nvGrpSpPr>
+        <p:cNvPr id="1" name=""/>
+        <p:cNvGrpSpPr/>
+        <p:nvPr/>
+      </p:nvGrpSpPr>
+      <p:grpSpPr>
+        <a:xfrm>
+          <a:off x="0" y="0"/>
+          <a:ext cx="0" cy="0"/>
+          <a:chOff x="0" y="0"/>
+          <a:chExt cx="0" cy="0"/>
+        </a:xfrm>
+      </p:grpSpPr>
+      <p:sp>
+        <p:nvSpPr>
+          <p:cNvPr id="2" name="Slide Image Placeholder 1"/>
+          <p:cNvSpPr>
+            <a:spLocks noGrp="1" noRot="1" noChangeAspect="1"/>
+          </p:cNvSpPr>
+          <p:nvPr>
+            <p:ph type="sldImg"/>
+          </p:nvPr>
+        </p:nvSpPr>
+        <p:spPr/>
+      </p:sp>
+      <p:sp>
+        <p:nvSpPr>
+          <p:cNvPr id="3" name="Notes Placeholder 2"/>
+          <p:cNvSpPr>
+            <a:spLocks noGrp="1"/>
+          </p:cNvSpPr>
+          <p:nvPr>
+            <p:ph type="body" idx="1"/>
+          </p:nvPr>
+        </p:nvSpPr>
+        <p:spPr/>
+        <p:txBody>
+          <a:bodyPr/>
+          <a:lstStyle/>
+          <a:p>
+            <a:r>
+              <a:rPr lang="en-US" dirty="0"/>
+              <a:t/>
+            </a:r>
+            <a:endParaRPr lang="en-US" dirty="0"/>
+          </a:p>
+        </p:txBody>
+      </p:sp>
+      <p:sp>
+        <p:nvSpPr>
+          <p:cNvPr id="4" name="Slide Number Placeholder 3"/>
+          <p:cNvSpPr>
+            <a:spLocks noGrp="1"/>
+          </p:cNvSpPr>
+          <p:nvPr>
+            <p:ph type="sldNum" sz="quarter" idx="10"/>
+          </p:nvPr>
+        </p:nvSpPr>
+        <p:spPr/>
+        <p:txBody>
+          <a:bodyPr/>
+          <a:lstStyle/>
+          <a:p>
+            <a:fld id="{F7021451-1387-4CA6-816F-3879F97B5CBC}" type="slidenum">
+              <a:rPr lang="en-US"/>
+              <a:t>9</a:t>
             </a:fld>
             <a:endParaRPr lang="en-US"/>
           </a:p>
@@ -1335,58 +1691,58 @@
                 <a:ea typeface="Arial" pitchFamily="34" charset="-122"/>
                 <a:cs typeface="Arial" pitchFamily="34" charset="-120"/>
               </a:rPr>
-              <a:t>Teach me Your way, O Lord, teach me Your way!</a:t>
-            </a:r>
-            <a:endParaRPr lang="en-US" sz="4800" dirty="0"/>
-          </a:p>
-          <a:p>
-            <a:pPr algn="ctr" indent="0" marL="0">
-              <a:buNone/>
-            </a:pPr>
-            <a:r>
-              <a:rPr lang="en-US" sz="4800" b="1" dirty="0">
-                <a:solidFill>
-                  <a:srgbClr val="FFFFFF"/>
-                </a:solidFill>
-                <a:latin typeface="Arial" pitchFamily="34" charset="0"/>
-                <a:ea typeface="Arial" pitchFamily="34" charset="-122"/>
-                <a:cs typeface="Arial" pitchFamily="34" charset="-120"/>
-              </a:rPr>
-              <a:t>Your guiding grace afford, teach me Your way!</a:t>
-            </a:r>
-            <a:endParaRPr lang="en-US" sz="4800" dirty="0"/>
-          </a:p>
-          <a:p>
-            <a:pPr algn="ctr" indent="0" marL="0">
-              <a:buNone/>
-            </a:pPr>
-            <a:r>
-              <a:rPr lang="en-US" sz="4800" b="1" dirty="0">
-                <a:solidFill>
-                  <a:srgbClr val="FFFFFF"/>
-                </a:solidFill>
-                <a:latin typeface="Arial" pitchFamily="34" charset="0"/>
-                <a:ea typeface="Arial" pitchFamily="34" charset="-122"/>
-                <a:cs typeface="Arial" pitchFamily="34" charset="-120"/>
-              </a:rPr>
-              <a:t>Help me to walk aright, more by faith, less by sight;</a:t>
-            </a:r>
-            <a:endParaRPr lang="en-US" sz="4800" dirty="0"/>
-          </a:p>
-          <a:p>
-            <a:pPr algn="ctr" indent="0" marL="0">
-              <a:buNone/>
-            </a:pPr>
-            <a:r>
-              <a:rPr lang="en-US" sz="4800" b="1" dirty="0">
-                <a:solidFill>
-                  <a:srgbClr val="FFFFFF"/>
-                </a:solidFill>
-                <a:latin typeface="Arial" pitchFamily="34" charset="0"/>
-                <a:ea typeface="Arial" pitchFamily="34" charset="-122"/>
-                <a:cs typeface="Arial" pitchFamily="34" charset="-120"/>
-              </a:rPr>
-              <a:t>Lead me with heavenly light, teach me Your way!</a:t>
+              <a:t>Teach me Your way, O Lord, </a:t>
+            </a:r>
+            <a:endParaRPr lang="en-US" sz="4800" dirty="0"/>
+          </a:p>
+          <a:p>
+            <a:pPr algn="ctr" indent="0" marL="0">
+              <a:buNone/>
+            </a:pPr>
+            <a:r>
+              <a:rPr lang="en-US" sz="4800" b="1" dirty="0">
+                <a:solidFill>
+                  <a:srgbClr val="FFFFFF"/>
+                </a:solidFill>
+                <a:latin typeface="Arial" pitchFamily="34" charset="0"/>
+                <a:ea typeface="Arial" pitchFamily="34" charset="-122"/>
+                <a:cs typeface="Arial" pitchFamily="34" charset="-120"/>
+              </a:rPr>
+              <a:t>teach me Your way!</a:t>
+            </a:r>
+            <a:endParaRPr lang="en-US" sz="4800" dirty="0"/>
+          </a:p>
+          <a:p>
+            <a:pPr algn="ctr" indent="0" marL="0">
+              <a:buNone/>
+            </a:pPr>
+            <a:r>
+              <a:rPr lang="en-US" sz="4800" b="1" dirty="0">
+                <a:solidFill>
+                  <a:srgbClr val="FFFFFF"/>
+                </a:solidFill>
+                <a:latin typeface="Arial" pitchFamily="34" charset="0"/>
+                <a:ea typeface="Arial" pitchFamily="34" charset="-122"/>
+                <a:cs typeface="Arial" pitchFamily="34" charset="-120"/>
+              </a:rPr>
+              <a:t>Your guiding grace afford, </a:t>
+            </a:r>
+            <a:endParaRPr lang="en-US" sz="4800" dirty="0"/>
+          </a:p>
+          <a:p>
+            <a:pPr algn="ctr" indent="0" marL="0">
+              <a:buNone/>
+            </a:pPr>
+            <a:r>
+              <a:rPr lang="en-US" sz="4800" b="1" dirty="0">
+                <a:solidFill>
+                  <a:srgbClr val="FFFFFF"/>
+                </a:solidFill>
+                <a:latin typeface="Arial" pitchFamily="34" charset="0"/>
+                <a:ea typeface="Arial" pitchFamily="34" charset="-122"/>
+                <a:cs typeface="Arial" pitchFamily="34" charset="-120"/>
+              </a:rPr>
+              <a:t>teach me Your way!</a:t>
             </a:r>
             <a:endParaRPr lang="en-US" sz="4800" dirty="0"/>
           </a:p>
@@ -1457,58 +1813,58 @@
                 <a:ea typeface="Arial" pitchFamily="34" charset="-122"/>
                 <a:cs typeface="Arial" pitchFamily="34" charset="-120"/>
               </a:rPr>
-              <a:t>When I am sad at heart, teach me Your way!</a:t>
-            </a:r>
-            <a:endParaRPr lang="en-US" sz="4800" dirty="0"/>
-          </a:p>
-          <a:p>
-            <a:pPr algn="ctr" indent="0" marL="0">
-              <a:buNone/>
-            </a:pPr>
-            <a:r>
-              <a:rPr lang="en-US" sz="4800" b="1" dirty="0">
-                <a:solidFill>
-                  <a:srgbClr val="FFFFFF"/>
-                </a:solidFill>
-                <a:latin typeface="Arial" pitchFamily="34" charset="0"/>
-                <a:ea typeface="Arial" pitchFamily="34" charset="-122"/>
-                <a:cs typeface="Arial" pitchFamily="34" charset="-120"/>
-              </a:rPr>
-              <a:t>When earthly joys depart, teach me Your way!</a:t>
-            </a:r>
-            <a:endParaRPr lang="en-US" sz="4800" dirty="0"/>
-          </a:p>
-          <a:p>
-            <a:pPr algn="ctr" indent="0" marL="0">
-              <a:buNone/>
-            </a:pPr>
-            <a:r>
-              <a:rPr lang="en-US" sz="4800" b="1" dirty="0">
-                <a:solidFill>
-                  <a:srgbClr val="FFFFFF"/>
-                </a:solidFill>
-                <a:latin typeface="Arial" pitchFamily="34" charset="0"/>
-                <a:ea typeface="Arial" pitchFamily="34" charset="-122"/>
-                <a:cs typeface="Arial" pitchFamily="34" charset="-120"/>
-              </a:rPr>
-              <a:t>In hours of loneliness, in times of dire distress,</a:t>
-            </a:r>
-            <a:endParaRPr lang="en-US" sz="4800" dirty="0"/>
-          </a:p>
-          <a:p>
-            <a:pPr algn="ctr" indent="0" marL="0">
-              <a:buNone/>
-            </a:pPr>
-            <a:r>
-              <a:rPr lang="en-US" sz="4800" b="1" dirty="0">
-                <a:solidFill>
-                  <a:srgbClr val="FFFFFF"/>
-                </a:solidFill>
-                <a:latin typeface="Arial" pitchFamily="34" charset="0"/>
-                <a:ea typeface="Arial" pitchFamily="34" charset="-122"/>
-                <a:cs typeface="Arial" pitchFamily="34" charset="-120"/>
-              </a:rPr>
-              <a:t>In failure or success, teach me Your way!</a:t>
+              <a:t>Help me to walk aright, </a:t>
+            </a:r>
+            <a:endParaRPr lang="en-US" sz="4800" dirty="0"/>
+          </a:p>
+          <a:p>
+            <a:pPr algn="ctr" indent="0" marL="0">
+              <a:buNone/>
+            </a:pPr>
+            <a:r>
+              <a:rPr lang="en-US" sz="4800" b="1" dirty="0">
+                <a:solidFill>
+                  <a:srgbClr val="FFFFFF"/>
+                </a:solidFill>
+                <a:latin typeface="Arial" pitchFamily="34" charset="0"/>
+                <a:ea typeface="Arial" pitchFamily="34" charset="-122"/>
+                <a:cs typeface="Arial" pitchFamily="34" charset="-120"/>
+              </a:rPr>
+              <a:t>more by faith, less by sight;</a:t>
+            </a:r>
+            <a:endParaRPr lang="en-US" sz="4800" dirty="0"/>
+          </a:p>
+          <a:p>
+            <a:pPr algn="ctr" indent="0" marL="0">
+              <a:buNone/>
+            </a:pPr>
+            <a:r>
+              <a:rPr lang="en-US" sz="4800" b="1" dirty="0">
+                <a:solidFill>
+                  <a:srgbClr val="FFFFFF"/>
+                </a:solidFill>
+                <a:latin typeface="Arial" pitchFamily="34" charset="0"/>
+                <a:ea typeface="Arial" pitchFamily="34" charset="-122"/>
+                <a:cs typeface="Arial" pitchFamily="34" charset="-120"/>
+              </a:rPr>
+              <a:t>Lead me with heavenly light, </a:t>
+            </a:r>
+            <a:endParaRPr lang="en-US" sz="4800" dirty="0"/>
+          </a:p>
+          <a:p>
+            <a:pPr algn="ctr" indent="0" marL="0">
+              <a:buNone/>
+            </a:pPr>
+            <a:r>
+              <a:rPr lang="en-US" sz="4800" b="1" dirty="0">
+                <a:solidFill>
+                  <a:srgbClr val="FFFFFF"/>
+                </a:solidFill>
+                <a:latin typeface="Arial" pitchFamily="34" charset="0"/>
+                <a:ea typeface="Arial" pitchFamily="34" charset="-122"/>
+                <a:cs typeface="Arial" pitchFamily="34" charset="-120"/>
+              </a:rPr>
+              <a:t>teach me Your way!</a:t>
             </a:r>
             <a:endParaRPr lang="en-US" sz="4800" dirty="0"/>
           </a:p>
@@ -1579,58 +1935,58 @@
                 <a:ea typeface="Arial" pitchFamily="34" charset="-122"/>
                 <a:cs typeface="Arial" pitchFamily="34" charset="-120"/>
               </a:rPr>
-              <a:t>When doubts and fears arise, teach me Your way!</a:t>
-            </a:r>
-            <a:endParaRPr lang="en-US" sz="4800" dirty="0"/>
-          </a:p>
-          <a:p>
-            <a:pPr algn="ctr" indent="0" marL="0">
-              <a:buNone/>
-            </a:pPr>
-            <a:r>
-              <a:rPr lang="en-US" sz="4800" b="1" dirty="0">
-                <a:solidFill>
-                  <a:srgbClr val="FFFFFF"/>
-                </a:solidFill>
-                <a:latin typeface="Arial" pitchFamily="34" charset="0"/>
-                <a:ea typeface="Arial" pitchFamily="34" charset="-122"/>
-                <a:cs typeface="Arial" pitchFamily="34" charset="-120"/>
-              </a:rPr>
-              <a:t>When storm clouds fill the skies, teach me Your way!</a:t>
-            </a:r>
-            <a:endParaRPr lang="en-US" sz="4800" dirty="0"/>
-          </a:p>
-          <a:p>
-            <a:pPr algn="ctr" indent="0" marL="0">
-              <a:buNone/>
-            </a:pPr>
-            <a:r>
-              <a:rPr lang="en-US" sz="4800" b="1" dirty="0">
-                <a:solidFill>
-                  <a:srgbClr val="FFFFFF"/>
-                </a:solidFill>
-                <a:latin typeface="Arial" pitchFamily="34" charset="0"/>
-                <a:ea typeface="Arial" pitchFamily="34" charset="-122"/>
-                <a:cs typeface="Arial" pitchFamily="34" charset="-120"/>
-              </a:rPr>
-              <a:t>Shine through the wind and rain, through sorrow, grief and pain;</a:t>
-            </a:r>
-            <a:endParaRPr lang="en-US" sz="4800" dirty="0"/>
-          </a:p>
-          <a:p>
-            <a:pPr algn="ctr" indent="0" marL="0">
-              <a:buNone/>
-            </a:pPr>
-            <a:r>
-              <a:rPr lang="en-US" sz="4800" b="1" dirty="0">
-                <a:solidFill>
-                  <a:srgbClr val="FFFFFF"/>
-                </a:solidFill>
-                <a:latin typeface="Arial" pitchFamily="34" charset="0"/>
-                <a:ea typeface="Arial" pitchFamily="34" charset="-122"/>
-                <a:cs typeface="Arial" pitchFamily="34" charset="-120"/>
-              </a:rPr>
-              <a:t>Make now my pathway plain, teach me Your way!</a:t>
+              <a:t>When I am sad at heart, </a:t>
+            </a:r>
+            <a:endParaRPr lang="en-US" sz="4800" dirty="0"/>
+          </a:p>
+          <a:p>
+            <a:pPr algn="ctr" indent="0" marL="0">
+              <a:buNone/>
+            </a:pPr>
+            <a:r>
+              <a:rPr lang="en-US" sz="4800" b="1" dirty="0">
+                <a:solidFill>
+                  <a:srgbClr val="FFFFFF"/>
+                </a:solidFill>
+                <a:latin typeface="Arial" pitchFamily="34" charset="0"/>
+                <a:ea typeface="Arial" pitchFamily="34" charset="-122"/>
+                <a:cs typeface="Arial" pitchFamily="34" charset="-120"/>
+              </a:rPr>
+              <a:t>teach me Your way!</a:t>
+            </a:r>
+            <a:endParaRPr lang="en-US" sz="4800" dirty="0"/>
+          </a:p>
+          <a:p>
+            <a:pPr algn="ctr" indent="0" marL="0">
+              <a:buNone/>
+            </a:pPr>
+            <a:r>
+              <a:rPr lang="en-US" sz="4800" b="1" dirty="0">
+                <a:solidFill>
+                  <a:srgbClr val="FFFFFF"/>
+                </a:solidFill>
+                <a:latin typeface="Arial" pitchFamily="34" charset="0"/>
+                <a:ea typeface="Arial" pitchFamily="34" charset="-122"/>
+                <a:cs typeface="Arial" pitchFamily="34" charset="-120"/>
+              </a:rPr>
+              <a:t>When earthly joys depart, </a:t>
+            </a:r>
+            <a:endParaRPr lang="en-US" sz="4800" dirty="0"/>
+          </a:p>
+          <a:p>
+            <a:pPr algn="ctr" indent="0" marL="0">
+              <a:buNone/>
+            </a:pPr>
+            <a:r>
+              <a:rPr lang="en-US" sz="4800" b="1" dirty="0">
+                <a:solidFill>
+                  <a:srgbClr val="FFFFFF"/>
+                </a:solidFill>
+                <a:latin typeface="Arial" pitchFamily="34" charset="0"/>
+                <a:ea typeface="Arial" pitchFamily="34" charset="-122"/>
+                <a:cs typeface="Arial" pitchFamily="34" charset="-120"/>
+              </a:rPr>
+              <a:t>teach me Your way!</a:t>
             </a:r>
             <a:endParaRPr lang="en-US" sz="4800" dirty="0"/>
           </a:p>
@@ -1701,59 +2057,553 @@
                 <a:ea typeface="Arial" pitchFamily="34" charset="-122"/>
                 <a:cs typeface="Arial" pitchFamily="34" charset="-120"/>
               </a:rPr>
-              <a:t>Long as my life shall last, teach me Your way!</a:t>
-            </a:r>
-            <a:endParaRPr lang="en-US" sz="4800" dirty="0"/>
-          </a:p>
-          <a:p>
-            <a:pPr algn="ctr" indent="0" marL="0">
-              <a:buNone/>
-            </a:pPr>
-            <a:r>
-              <a:rPr lang="en-US" sz="4800" b="1" dirty="0">
-                <a:solidFill>
-                  <a:srgbClr val="FFFFFF"/>
-                </a:solidFill>
-                <a:latin typeface="Arial" pitchFamily="34" charset="0"/>
-                <a:ea typeface="Arial" pitchFamily="34" charset="-122"/>
-                <a:cs typeface="Arial" pitchFamily="34" charset="-120"/>
-              </a:rPr>
-              <a:t>Where’er my lot be cast, teach me Your way!</a:t>
-            </a:r>
-            <a:endParaRPr lang="en-US" sz="4800" dirty="0"/>
-          </a:p>
-          <a:p>
-            <a:pPr algn="ctr" indent="0" marL="0">
-              <a:buNone/>
-            </a:pPr>
-            <a:r>
-              <a:rPr lang="en-US" sz="4800" b="1" dirty="0">
-                <a:solidFill>
-                  <a:srgbClr val="FFFFFF"/>
-                </a:solidFill>
-                <a:latin typeface="Arial" pitchFamily="34" charset="0"/>
-                <a:ea typeface="Arial" pitchFamily="34" charset="-122"/>
-                <a:cs typeface="Arial" pitchFamily="34" charset="-120"/>
-              </a:rPr>
-              <a:t>Until the race is run, until the journey’s done,</a:t>
-            </a:r>
-            <a:endParaRPr lang="en-US" sz="4800" dirty="0"/>
-          </a:p>
-          <a:p>
-            <a:pPr algn="ctr" indent="0" marL="0">
-              <a:buNone/>
-            </a:pPr>
-            <a:r>
-              <a:rPr lang="en-US" sz="4800" b="1" dirty="0">
-                <a:solidFill>
-                  <a:srgbClr val="FFFFFF"/>
-                </a:solidFill>
-                <a:latin typeface="Arial" pitchFamily="34" charset="0"/>
-                <a:ea typeface="Arial" pitchFamily="34" charset="-122"/>
-                <a:cs typeface="Arial" pitchFamily="34" charset="-120"/>
-              </a:rPr>
-              <a:t>Until the crown is won, teach me Your way!</a:t>
-            </a:r>
+              <a:t>In hours of loneliness, </a:t>
+            </a:r>
+            <a:endParaRPr lang="en-US" sz="4800" dirty="0"/>
+          </a:p>
+          <a:p>
+            <a:pPr algn="ctr" indent="0" marL="0">
+              <a:buNone/>
+            </a:pPr>
+            <a:r>
+              <a:rPr lang="en-US" sz="4800" b="1" dirty="0">
+                <a:solidFill>
+                  <a:srgbClr val="FFFFFF"/>
+                </a:solidFill>
+                <a:latin typeface="Arial" pitchFamily="34" charset="0"/>
+                <a:ea typeface="Arial" pitchFamily="34" charset="-122"/>
+                <a:cs typeface="Arial" pitchFamily="34" charset="-120"/>
+              </a:rPr>
+              <a:t>in times of dire distress,</a:t>
+            </a:r>
+            <a:endParaRPr lang="en-US" sz="4800" dirty="0"/>
+          </a:p>
+          <a:p>
+            <a:pPr algn="ctr" indent="0" marL="0">
+              <a:buNone/>
+            </a:pPr>
+            <a:r>
+              <a:rPr lang="en-US" sz="4800" b="1" dirty="0">
+                <a:solidFill>
+                  <a:srgbClr val="FFFFFF"/>
+                </a:solidFill>
+                <a:latin typeface="Arial" pitchFamily="34" charset="0"/>
+                <a:ea typeface="Arial" pitchFamily="34" charset="-122"/>
+                <a:cs typeface="Arial" pitchFamily="34" charset="-120"/>
+              </a:rPr>
+              <a:t>In failure or success, </a:t>
+            </a:r>
+            <a:endParaRPr lang="en-US" sz="4800" dirty="0"/>
+          </a:p>
+          <a:p>
+            <a:pPr algn="ctr" indent="0" marL="0">
+              <a:buNone/>
+            </a:pPr>
+            <a:r>
+              <a:rPr lang="en-US" sz="4800" b="1" dirty="0">
+                <a:solidFill>
+                  <a:srgbClr val="FFFFFF"/>
+                </a:solidFill>
+                <a:latin typeface="Arial" pitchFamily="34" charset="0"/>
+                <a:ea typeface="Arial" pitchFamily="34" charset="-122"/>
+                <a:cs typeface="Arial" pitchFamily="34" charset="-120"/>
+              </a:rPr>
+              <a:t>teach me Your way!</a:t>
+            </a:r>
+            <a:endParaRPr lang="en-US" sz="4800" dirty="0"/>
+          </a:p>
+        </p:txBody>
+      </p:sp>
+    </p:spTree>
+  </p:cSld>
+  <p:clrMapOvr>
+    <a:masterClrMapping/>
+  </p:clrMapOvr>
+</p:sld>
+</file>
+
+<file path=ppt/slides/slide6.xml><?xml version="1.0" encoding="utf-8"?>
+<p:sld xmlns:a="http://schemas.openxmlformats.org/drawingml/2006/main" xmlns:r="http://schemas.openxmlformats.org/officeDocument/2006/relationships" xmlns:p="http://schemas.openxmlformats.org/presentationml/2006/main">
+  <p:cSld name="Slide 6">
+    <p:bg>
+      <p:bgPr>
+        <a:solidFill>
+          <a:srgbClr val="000000"/>
+        </a:solidFill>
+      </p:bgPr>
+    </p:bg>
+    <p:spTree>
+      <p:nvGrpSpPr>
+        <p:cNvPr id="1" name=""/>
+        <p:cNvGrpSpPr/>
+        <p:nvPr/>
+      </p:nvGrpSpPr>
+      <p:grpSpPr>
+        <a:xfrm>
+          <a:off x="0" y="0"/>
+          <a:ext cx="0" cy="0"/>
+          <a:chOff x="0" y="0"/>
+          <a:chExt cx="0" cy="0"/>
+        </a:xfrm>
+      </p:grpSpPr>
+      <p:sp>
+        <p:nvSpPr>
+          <p:cNvPr id="2" name="Text 0"/>
+          <p:cNvSpPr txBox="1"/>
+          <p:nvPr/>
+        </p:nvSpPr>
+        <p:spPr>
+          <a:xfrm>
+            <a:off x="548640" y="457200"/>
+            <a:ext cx="11064240" cy="5943600"/>
+          </a:xfrm>
+          <a:prstGeom prst="rect">
+            <a:avLst/>
+          </a:prstGeom>
+          <a:noFill/>
+          <a:ln/>
+        </p:spPr>
+        <p:txBody>
+          <a:bodyPr wrap="square" lIns="0" tIns="0" rIns="0" bIns="0" rtlCol="0" anchor="ctr"/>
+          <a:lstStyle/>
+          <a:p>
+            <a:pPr algn="ctr" indent="0" marL="0">
+              <a:buNone/>
+            </a:pPr>
+            <a:r>
+              <a:rPr lang="en-US" sz="4800" b="1" dirty="0">
+                <a:solidFill>
+                  <a:srgbClr val="FFFFFF"/>
+                </a:solidFill>
+                <a:latin typeface="Arial" pitchFamily="34" charset="0"/>
+                <a:ea typeface="Arial" pitchFamily="34" charset="-122"/>
+                <a:cs typeface="Arial" pitchFamily="34" charset="-120"/>
+              </a:rPr>
+              <a:t>When doubts and fears arise, </a:t>
+            </a:r>
+            <a:endParaRPr lang="en-US" sz="4800" dirty="0"/>
+          </a:p>
+          <a:p>
+            <a:pPr algn="ctr" indent="0" marL="0">
+              <a:buNone/>
+            </a:pPr>
+            <a:r>
+              <a:rPr lang="en-US" sz="4800" b="1" dirty="0">
+                <a:solidFill>
+                  <a:srgbClr val="FFFFFF"/>
+                </a:solidFill>
+                <a:latin typeface="Arial" pitchFamily="34" charset="0"/>
+                <a:ea typeface="Arial" pitchFamily="34" charset="-122"/>
+                <a:cs typeface="Arial" pitchFamily="34" charset="-120"/>
+              </a:rPr>
+              <a:t>teach me Your way!</a:t>
+            </a:r>
+            <a:endParaRPr lang="en-US" sz="4800" dirty="0"/>
+          </a:p>
+          <a:p>
+            <a:pPr algn="ctr" indent="0" marL="0">
+              <a:buNone/>
+            </a:pPr>
+            <a:r>
+              <a:rPr lang="en-US" sz="4800" b="1" dirty="0">
+                <a:solidFill>
+                  <a:srgbClr val="FFFFFF"/>
+                </a:solidFill>
+                <a:latin typeface="Arial" pitchFamily="34" charset="0"/>
+                <a:ea typeface="Arial" pitchFamily="34" charset="-122"/>
+                <a:cs typeface="Arial" pitchFamily="34" charset="-120"/>
+              </a:rPr>
+              <a:t>When storm clouds fill the skies, </a:t>
+            </a:r>
+            <a:endParaRPr lang="en-US" sz="4800" dirty="0"/>
+          </a:p>
+          <a:p>
+            <a:pPr algn="ctr" indent="0" marL="0">
+              <a:buNone/>
+            </a:pPr>
+            <a:r>
+              <a:rPr lang="en-US" sz="4800" b="1" dirty="0">
+                <a:solidFill>
+                  <a:srgbClr val="FFFFFF"/>
+                </a:solidFill>
+                <a:latin typeface="Arial" pitchFamily="34" charset="0"/>
+                <a:ea typeface="Arial" pitchFamily="34" charset="-122"/>
+                <a:cs typeface="Arial" pitchFamily="34" charset="-120"/>
+              </a:rPr>
+              <a:t>teach me Your way!</a:t>
+            </a:r>
+            <a:endParaRPr lang="en-US" sz="4800" dirty="0"/>
+          </a:p>
+        </p:txBody>
+      </p:sp>
+    </p:spTree>
+  </p:cSld>
+  <p:clrMapOvr>
+    <a:masterClrMapping/>
+  </p:clrMapOvr>
+</p:sld>
+</file>
+
+<file path=ppt/slides/slide7.xml><?xml version="1.0" encoding="utf-8"?>
+<p:sld xmlns:a="http://schemas.openxmlformats.org/drawingml/2006/main" xmlns:r="http://schemas.openxmlformats.org/officeDocument/2006/relationships" xmlns:p="http://schemas.openxmlformats.org/presentationml/2006/main">
+  <p:cSld name="Slide 7">
+    <p:bg>
+      <p:bgPr>
+        <a:solidFill>
+          <a:srgbClr val="000000"/>
+        </a:solidFill>
+      </p:bgPr>
+    </p:bg>
+    <p:spTree>
+      <p:nvGrpSpPr>
+        <p:cNvPr id="1" name=""/>
+        <p:cNvGrpSpPr/>
+        <p:nvPr/>
+      </p:nvGrpSpPr>
+      <p:grpSpPr>
+        <a:xfrm>
+          <a:off x="0" y="0"/>
+          <a:ext cx="0" cy="0"/>
+          <a:chOff x="0" y="0"/>
+          <a:chExt cx="0" cy="0"/>
+        </a:xfrm>
+      </p:grpSpPr>
+      <p:sp>
+        <p:nvSpPr>
+          <p:cNvPr id="2" name="Text 0"/>
+          <p:cNvSpPr txBox="1"/>
+          <p:nvPr/>
+        </p:nvSpPr>
+        <p:spPr>
+          <a:xfrm>
+            <a:off x="548640" y="457200"/>
+            <a:ext cx="11064240" cy="5943600"/>
+          </a:xfrm>
+          <a:prstGeom prst="rect">
+            <a:avLst/>
+          </a:prstGeom>
+          <a:noFill/>
+          <a:ln/>
+        </p:spPr>
+        <p:txBody>
+          <a:bodyPr wrap="square" lIns="0" tIns="0" rIns="0" bIns="0" rtlCol="0" anchor="ctr"/>
+          <a:lstStyle/>
+          <a:p>
+            <a:pPr algn="ctr" indent="0" marL="0">
+              <a:buNone/>
+            </a:pPr>
+            <a:r>
+              <a:rPr lang="en-US" sz="4800" b="1" dirty="0">
+                <a:solidFill>
+                  <a:srgbClr val="FFFFFF"/>
+                </a:solidFill>
+                <a:latin typeface="Arial" pitchFamily="34" charset="0"/>
+                <a:ea typeface="Arial" pitchFamily="34" charset="-122"/>
+                <a:cs typeface="Arial" pitchFamily="34" charset="-120"/>
+              </a:rPr>
+              <a:t>Shine through the wind and rain, </a:t>
+            </a:r>
+            <a:endParaRPr lang="en-US" sz="4800" dirty="0"/>
+          </a:p>
+          <a:p>
+            <a:pPr algn="ctr" indent="0" marL="0">
+              <a:buNone/>
+            </a:pPr>
+            <a:r>
+              <a:rPr lang="en-US" sz="4800" b="1" dirty="0">
+                <a:solidFill>
+                  <a:srgbClr val="FFFFFF"/>
+                </a:solidFill>
+                <a:latin typeface="Arial" pitchFamily="34" charset="0"/>
+                <a:ea typeface="Arial" pitchFamily="34" charset="-122"/>
+                <a:cs typeface="Arial" pitchFamily="34" charset="-120"/>
+              </a:rPr>
+              <a:t>through sorrow, grief and pain;</a:t>
+            </a:r>
+            <a:endParaRPr lang="en-US" sz="4800" dirty="0"/>
+          </a:p>
+          <a:p>
+            <a:pPr algn="ctr" indent="0" marL="0">
+              <a:buNone/>
+            </a:pPr>
+            <a:r>
+              <a:rPr lang="en-US" sz="4800" b="1" dirty="0">
+                <a:solidFill>
+                  <a:srgbClr val="FFFFFF"/>
+                </a:solidFill>
+                <a:latin typeface="Arial" pitchFamily="34" charset="0"/>
+                <a:ea typeface="Arial" pitchFamily="34" charset="-122"/>
+                <a:cs typeface="Arial" pitchFamily="34" charset="-120"/>
+              </a:rPr>
+              <a:t>Make now my pathway plain, </a:t>
+            </a:r>
+            <a:endParaRPr lang="en-US" sz="4800" dirty="0"/>
+          </a:p>
+          <a:p>
+            <a:pPr algn="ctr" indent="0" marL="0">
+              <a:buNone/>
+            </a:pPr>
+            <a:r>
+              <a:rPr lang="en-US" sz="4800" b="1" dirty="0">
+                <a:solidFill>
+                  <a:srgbClr val="FFFFFF"/>
+                </a:solidFill>
+                <a:latin typeface="Arial" pitchFamily="34" charset="0"/>
+                <a:ea typeface="Arial" pitchFamily="34" charset="-122"/>
+                <a:cs typeface="Arial" pitchFamily="34" charset="-120"/>
+              </a:rPr>
+              <a:t>teach me Your way!</a:t>
+            </a:r>
+            <a:endParaRPr lang="en-US" sz="4800" dirty="0"/>
+          </a:p>
+        </p:txBody>
+      </p:sp>
+    </p:spTree>
+  </p:cSld>
+  <p:clrMapOvr>
+    <a:masterClrMapping/>
+  </p:clrMapOvr>
+</p:sld>
+</file>
+
+<file path=ppt/slides/slide8.xml><?xml version="1.0" encoding="utf-8"?>
+<p:sld xmlns:a="http://schemas.openxmlformats.org/drawingml/2006/main" xmlns:r="http://schemas.openxmlformats.org/officeDocument/2006/relationships" xmlns:p="http://schemas.openxmlformats.org/presentationml/2006/main">
+  <p:cSld name="Slide 8">
+    <p:bg>
+      <p:bgPr>
+        <a:solidFill>
+          <a:srgbClr val="000000"/>
+        </a:solidFill>
+      </p:bgPr>
+    </p:bg>
+    <p:spTree>
+      <p:nvGrpSpPr>
+        <p:cNvPr id="1" name=""/>
+        <p:cNvGrpSpPr/>
+        <p:nvPr/>
+      </p:nvGrpSpPr>
+      <p:grpSpPr>
+        <a:xfrm>
+          <a:off x="0" y="0"/>
+          <a:ext cx="0" cy="0"/>
+          <a:chOff x="0" y="0"/>
+          <a:chExt cx="0" cy="0"/>
+        </a:xfrm>
+      </p:grpSpPr>
+      <p:sp>
+        <p:nvSpPr>
+          <p:cNvPr id="2" name="Text 0"/>
+          <p:cNvSpPr txBox="1"/>
+          <p:nvPr/>
+        </p:nvSpPr>
+        <p:spPr>
+          <a:xfrm>
+            <a:off x="548640" y="457200"/>
+            <a:ext cx="11064240" cy="5943600"/>
+          </a:xfrm>
+          <a:prstGeom prst="rect">
+            <a:avLst/>
+          </a:prstGeom>
+          <a:noFill/>
+          <a:ln/>
+        </p:spPr>
+        <p:txBody>
+          <a:bodyPr wrap="square" lIns="0" tIns="0" rIns="0" bIns="0" rtlCol="0" anchor="ctr"/>
+          <a:lstStyle/>
+          <a:p>
+            <a:pPr algn="ctr" indent="0" marL="0">
+              <a:buNone/>
+            </a:pPr>
+            <a:r>
+              <a:rPr lang="en-US" sz="4800" b="1" dirty="0">
+                <a:solidFill>
+                  <a:srgbClr val="FFFFFF"/>
+                </a:solidFill>
+                <a:latin typeface="Arial" pitchFamily="34" charset="0"/>
+                <a:ea typeface="Arial" pitchFamily="34" charset="-122"/>
+                <a:cs typeface="Arial" pitchFamily="34" charset="-120"/>
+              </a:rPr>
+              <a:t>Long as my life shall last, </a:t>
+            </a:r>
+            <a:endParaRPr lang="en-US" sz="4800" dirty="0"/>
+          </a:p>
+          <a:p>
+            <a:pPr algn="ctr" indent="0" marL="0">
+              <a:buNone/>
+            </a:pPr>
+            <a:r>
+              <a:rPr lang="en-US" sz="4800" b="1" dirty="0">
+                <a:solidFill>
+                  <a:srgbClr val="FFFFFF"/>
+                </a:solidFill>
+                <a:latin typeface="Arial" pitchFamily="34" charset="0"/>
+                <a:ea typeface="Arial" pitchFamily="34" charset="-122"/>
+                <a:cs typeface="Arial" pitchFamily="34" charset="-120"/>
+              </a:rPr>
+              <a:t>teach me Your way!</a:t>
+            </a:r>
+            <a:endParaRPr lang="en-US" sz="4800" dirty="0"/>
+          </a:p>
+          <a:p>
+            <a:pPr algn="ctr" indent="0" marL="0">
+              <a:buNone/>
+            </a:pPr>
+            <a:r>
+              <a:rPr lang="en-US" sz="4800" b="1" dirty="0">
+                <a:solidFill>
+                  <a:srgbClr val="FFFFFF"/>
+                </a:solidFill>
+                <a:latin typeface="Arial" pitchFamily="34" charset="0"/>
+                <a:ea typeface="Arial" pitchFamily="34" charset="-122"/>
+                <a:cs typeface="Arial" pitchFamily="34" charset="-120"/>
+              </a:rPr>
+              <a:t>Where’er my lot be cast, </a:t>
+            </a:r>
+            <a:endParaRPr lang="en-US" sz="4800" dirty="0"/>
+          </a:p>
+          <a:p>
+            <a:pPr algn="ctr" indent="0" marL="0">
+              <a:buNone/>
+            </a:pPr>
+            <a:r>
+              <a:rPr lang="en-US" sz="4800" b="1" dirty="0">
+                <a:solidFill>
+                  <a:srgbClr val="FFFFFF"/>
+                </a:solidFill>
+                <a:latin typeface="Arial" pitchFamily="34" charset="0"/>
+                <a:ea typeface="Arial" pitchFamily="34" charset="-122"/>
+                <a:cs typeface="Arial" pitchFamily="34" charset="-120"/>
+              </a:rPr>
+              <a:t>teach me Your way!</a:t>
+            </a:r>
+            <a:endParaRPr lang="en-US" sz="4800" dirty="0"/>
+          </a:p>
+        </p:txBody>
+      </p:sp>
+    </p:spTree>
+  </p:cSld>
+  <p:clrMapOvr>
+    <a:masterClrMapping/>
+  </p:clrMapOvr>
+</p:sld>
+</file>
+
+<file path=ppt/slides/slide9.xml><?xml version="1.0" encoding="utf-8"?>
+<p:sld xmlns:a="http://schemas.openxmlformats.org/drawingml/2006/main" xmlns:r="http://schemas.openxmlformats.org/officeDocument/2006/relationships" xmlns:p="http://schemas.openxmlformats.org/presentationml/2006/main">
+  <p:cSld name="Slide 9">
+    <p:bg>
+      <p:bgPr>
+        <a:solidFill>
+          <a:srgbClr val="000000"/>
+        </a:solidFill>
+      </p:bgPr>
+    </p:bg>
+    <p:spTree>
+      <p:nvGrpSpPr>
+        <p:cNvPr id="1" name=""/>
+        <p:cNvGrpSpPr/>
+        <p:nvPr/>
+      </p:nvGrpSpPr>
+      <p:grpSpPr>
+        <a:xfrm>
+          <a:off x="0" y="0"/>
+          <a:ext cx="0" cy="0"/>
+          <a:chOff x="0" y="0"/>
+          <a:chExt cx="0" cy="0"/>
+        </a:xfrm>
+      </p:grpSpPr>
+      <p:sp>
+        <p:nvSpPr>
+          <p:cNvPr id="2" name="Text 0"/>
+          <p:cNvSpPr txBox="1"/>
+          <p:nvPr/>
+        </p:nvSpPr>
+        <p:spPr>
+          <a:xfrm>
+            <a:off x="548640" y="457200"/>
+            <a:ext cx="11064240" cy="5943600"/>
+          </a:xfrm>
+          <a:prstGeom prst="rect">
+            <a:avLst/>
+          </a:prstGeom>
+          <a:noFill/>
+          <a:ln/>
+        </p:spPr>
+        <p:txBody>
+          <a:bodyPr wrap="square" lIns="0" tIns="0" rIns="0" bIns="0" rtlCol="0" anchor="ctr"/>
+          <a:lstStyle/>
+          <a:p>
+            <a:pPr algn="ctr" indent="0" marL="0">
+              <a:buNone/>
+            </a:pPr>
+            <a:r>
+              <a:rPr lang="en-US" sz="4800" b="1" dirty="0">
+                <a:solidFill>
+                  <a:srgbClr val="FFFFFF"/>
+                </a:solidFill>
+                <a:latin typeface="Arial" pitchFamily="34" charset="0"/>
+                <a:ea typeface="Arial" pitchFamily="34" charset="-122"/>
+                <a:cs typeface="Arial" pitchFamily="34" charset="-120"/>
+              </a:rPr>
+              <a:t>Until the race is run, </a:t>
+            </a:r>
+            <a:endParaRPr lang="en-US" sz="4800" dirty="0"/>
+          </a:p>
+          <a:p>
+            <a:pPr algn="ctr" indent="0" marL="0">
+              <a:buNone/>
+            </a:pPr>
+            <a:r>
+              <a:rPr lang="en-US" sz="4800" b="1" dirty="0">
+                <a:solidFill>
+                  <a:srgbClr val="FFFFFF"/>
+                </a:solidFill>
+                <a:latin typeface="Arial" pitchFamily="34" charset="0"/>
+                <a:ea typeface="Arial" pitchFamily="34" charset="-122"/>
+                <a:cs typeface="Arial" pitchFamily="34" charset="-120"/>
+              </a:rPr>
+              <a:t>until the journey’s done,</a:t>
+            </a:r>
+            <a:endParaRPr lang="en-US" sz="4800" dirty="0"/>
+          </a:p>
+          <a:p>
+            <a:pPr algn="ctr" indent="0" marL="0">
+              <a:buNone/>
+            </a:pPr>
+            <a:r>
+              <a:rPr lang="en-US" sz="4800" b="1" dirty="0">
+                <a:solidFill>
+                  <a:srgbClr val="FFFFFF"/>
+                </a:solidFill>
+                <a:latin typeface="Arial" pitchFamily="34" charset="0"/>
+                <a:ea typeface="Arial" pitchFamily="34" charset="-122"/>
+                <a:cs typeface="Arial" pitchFamily="34" charset="-120"/>
+              </a:rPr>
+              <a:t>Until the crown is won, </a:t>
+            </a:r>
+            <a:endParaRPr lang="en-US" sz="4800" dirty="0"/>
+          </a:p>
+          <a:p>
+            <a:pPr algn="ctr" indent="0" marL="0">
+              <a:buNone/>
+            </a:pPr>
+            <a:r>
+              <a:rPr lang="en-US" sz="4800" b="1" dirty="0">
+                <a:solidFill>
+                  <a:srgbClr val="FFFFFF"/>
+                </a:solidFill>
+                <a:latin typeface="Arial" pitchFamily="34" charset="0"/>
+                <a:ea typeface="Arial" pitchFamily="34" charset="-122"/>
+                <a:cs typeface="Arial" pitchFamily="34" charset="-120"/>
+              </a:rPr>
+              <a:t>teach me Your way!</a:t>
+            </a:r>
+            <a:endParaRPr lang="en-US" sz="4800" dirty="0"/>
+          </a:p>
+          <a:p>
+            <a:pPr algn="ctr" indent="0" marL="0">
+              <a:buNone/>
+            </a:pPr>
             <a:endParaRPr lang="en-US" sz="4800" dirty="0"/>
           </a:p>
           <a:p>

</xml_diff>